<commit_message>
Initial software engineering project submission
</commit_message>
<xml_diff>
--- a/tools/bcard/Presentation.pptx
+++ b/tools/bcard/Presentation.pptx
@@ -6323,6 +6323,13 @@
   <p:clrMapOvr>
     <a:masterClrMapping/>
   </p:clrMapOvr>
+  <p:timing>
+    <p:tnLst>
+      <p:par>
+        <p:cTn id="1" dur="indefinite" restart="never" nodeType="tmRoot"/>
+      </p:par>
+    </p:tnLst>
+  </p:timing>
 </p:sld>
 </file>
 
@@ -7046,6 +7053,13 @@
   <p:clrMapOvr>
     <a:masterClrMapping/>
   </p:clrMapOvr>
+  <p:timing>
+    <p:tnLst>
+      <p:par>
+        <p:cTn id="1" dur="indefinite" restart="never" nodeType="tmRoot"/>
+      </p:par>
+    </p:tnLst>
+  </p:timing>
 </p:sld>
 </file>
 
@@ -7474,6 +7488,13 @@
   <p:clrMapOvr>
     <a:masterClrMapping/>
   </p:clrMapOvr>
+  <p:timing>
+    <p:tnLst>
+      <p:par>
+        <p:cTn id="1" dur="indefinite" restart="never" nodeType="tmRoot"/>
+      </p:par>
+    </p:tnLst>
+  </p:timing>
 </p:sld>
 </file>
 
@@ -8042,6 +8063,13 @@
   <p:clrMapOvr>
     <a:masterClrMapping/>
   </p:clrMapOvr>
+  <p:timing>
+    <p:tnLst>
+      <p:par>
+        <p:cTn id="1" dur="indefinite" restart="never" nodeType="tmRoot"/>
+      </p:par>
+    </p:tnLst>
+  </p:timing>
 </p:sld>
 </file>
 
@@ -8533,6 +8561,13 @@
   <p:clrMapOvr>
     <a:masterClrMapping/>
   </p:clrMapOvr>
+  <p:timing>
+    <p:tnLst>
+      <p:par>
+        <p:cTn id="1" dur="indefinite" restart="never" nodeType="tmRoot"/>
+      </p:par>
+    </p:tnLst>
+  </p:timing>
 </p:sld>
 </file>
 
@@ -8876,6 +8911,13 @@
   <p:clrMapOvr>
     <a:masterClrMapping/>
   </p:clrMapOvr>
+  <p:timing>
+    <p:tnLst>
+      <p:par>
+        <p:cTn id="1" dur="indefinite" restart="never" nodeType="tmRoot"/>
+      </p:par>
+    </p:tnLst>
+  </p:timing>
 </p:sld>
 </file>
 
@@ -9216,30 +9258,20 @@
           </a:bodyPr>
           <a:lstStyle/>
           <a:p>
+            <a:pPr marL="0" indent="0">
+              <a:buNone/>
+            </a:pPr>
             <a:r>
               <a:rPr lang="en-US" dirty="0">
-                <a:latin typeface="Aptos"/>
                 <a:ea typeface="+mn-lt"/>
                 <a:cs typeface="Arial"/>
+                <a:hlinkClick r:id="rId2"/>
               </a:rPr>
-              <a:t>Informal testing</a:t>
-            </a:r>
-          </a:p>
-          <a:p>
-            <a:r>
-              <a:rPr lang="en-US" dirty="0">
-                <a:cs typeface="Arial"/>
-              </a:rPr>
-              <a:t>Accessibility</a:t>
-            </a:r>
-          </a:p>
-          <a:p>
-            <a:r>
-              <a:rPr lang="en-US" dirty="0">
-                <a:cs typeface="Arial"/>
-              </a:rPr>
-              <a:t>Mobile responsiveness</a:t>
-            </a:r>
+              <a:t>https://harveypw0503.github.io/Software_Engineering_Project_Submission/tools/bcard/bcard.html</a:t>
+            </a:r>
+            <a:endParaRPr lang="en-US" dirty="0">
+              <a:cs typeface="Arial"/>
+            </a:endParaRPr>
           </a:p>
         </p:txBody>
       </p:sp>
@@ -9258,7 +9290,7 @@
           <p:nvPr/>
         </p:nvPicPr>
         <p:blipFill>
-          <a:blip r:embed="rId2"/>
+          <a:blip r:embed="rId3"/>
           <a:stretch>
             <a:fillRect/>
           </a:stretch>
@@ -9283,6 +9315,13 @@
   <p:clrMapOvr>
     <a:masterClrMapping/>
   </p:clrMapOvr>
+  <p:timing>
+    <p:tnLst>
+      <p:par>
+        <p:cTn id="1" dur="indefinite" restart="never" nodeType="tmRoot"/>
+      </p:par>
+    </p:tnLst>
+  </p:timing>
 </p:sld>
 </file>
 
@@ -9734,6 +9773,13 @@
   <p:clrMapOvr>
     <a:masterClrMapping/>
   </p:clrMapOvr>
+  <p:timing>
+    <p:tnLst>
+      <p:par>
+        <p:cTn id="1" dur="indefinite" restart="never" nodeType="tmRoot"/>
+      </p:par>
+    </p:tnLst>
+  </p:timing>
 </p:sld>
 </file>
 

</xml_diff>